<commit_message>
fix pdf and pptx
</commit_message>
<xml_diff>
--- a/deliverables/slides/slides.pptx
+++ b/deliverables/slides/slides.pptx
@@ -10724,7 +10724,7 @@
         <p:spPr>
           <a:xfrm>
             <a:off x="713232" y="1205568"/>
-            <a:ext cx="10765231" cy="1371600"/>
+            <a:ext cx="10765231" cy="1097280"/>
           </a:xfrm>
           <a:prstGeom prst="rect">
             <a:avLst/>
@@ -10770,10 +10770,19 @@
                 <a:spcPts val="1000"/>
               </a:spcBef>
               <a:spcAft>
-                <a:spcPts val="400"/>
+                <a:spcPts val="300"/>
               </a:spcAft>
             </a:pPr>
             <a:r>
+              <a:rPr sz="1600">
+                <a:solidFill>
+                  <a:srgbClr val="7EE787"/>
+                </a:solidFill>
+                <a:latin typeface="Inter"/>
+              </a:rPr>
+              <a:t>•  </a:t>
+            </a:r>
+            <a:r>
               <a:rPr sz="1600" b="1">
                 <a:solidFill>
                   <a:srgbClr val="7EE787"/>
@@ -10789,7 +10798,7 @@
                 </a:solidFill>
                 <a:latin typeface="Inter"/>
               </a:rPr>
-              <a:t>: Query all eligible nodes with ego-graph prompts. Solve Max-2SAT per node (NCO constraints + LLM soft scores). </a:t>
+              <a:t>: Query all eligible nodes with ego-graph prompts. Solve Max-2SAT per node. </a:t>
             </a:r>
             <a:r>
               <a:rPr sz="1600" b="1">
@@ -10807,19 +10816,28 @@
                 </a:solidFill>
                 <a:latin typeface="Inter"/>
               </a:rPr>
-              <a:t>: commit edges where majority vote &gt; 70%.</a:t>
+              <a:t> edges where majority vote &gt; 70%.</a:t>
             </a:r>
           </a:p>
           <a:p>
             <a:pPr>
               <a:spcBef>
-                <a:spcPts val="1000"/>
+                <a:spcPts val="200"/>
               </a:spcBef>
               <a:spcAft>
-                <a:spcPts val="400"/>
+                <a:spcPts val="300"/>
               </a:spcAft>
             </a:pPr>
             <a:r>
+              <a:rPr sz="1600">
+                <a:solidFill>
+                  <a:srgbClr val="7EE787"/>
+                </a:solidFill>
+                <a:latin typeface="Inter"/>
+              </a:rPr>
+              <a:t>•  </a:t>
+            </a:r>
+            <a:r>
               <a:rPr sz="1600" b="1">
                 <a:solidFill>
                   <a:srgbClr val="7EE787"/>
@@ -10853,7 +10871,7 @@
                 </a:solidFill>
                 <a:latin typeface="Inter"/>
               </a:rPr>
-              <a:t> — those adjacent to established edges but not yet queried. Prompts now include established orientations as context. Max-2SAT adds established edges as </a:t>
+              <a:t> adjacent to established edges. Established orientations become </a:t>
             </a:r>
             <a:r>
               <a:rPr sz="1600" b="1">
@@ -10862,7 +10880,7 @@
                 </a:solidFill>
                 <a:latin typeface="Inter"/>
               </a:rPr>
-              <a:t>hard unary constraints</a:t>
+              <a:t>hard constraints</a:t>
             </a:r>
             <a:r>
               <a:rPr sz="1600">
@@ -10871,19 +10889,28 @@
                 </a:solidFill>
                 <a:latin typeface="Inter"/>
               </a:rPr>
-              <a:t>. Decimate new high-confidence edges. Repeat.</a:t>
+              <a:t>. Decimate and repeat.</a:t>
             </a:r>
           </a:p>
           <a:p>
             <a:pPr>
               <a:spcBef>
-                <a:spcPts val="1000"/>
+                <a:spcPts val="200"/>
               </a:spcBef>
               <a:spcAft>
-                <a:spcPts val="400"/>
+                <a:spcPts val="300"/>
               </a:spcAft>
             </a:pPr>
             <a:r>
+              <a:rPr sz="1600">
+                <a:solidFill>
+                  <a:srgbClr val="7EE787"/>
+                </a:solidFill>
+                <a:latin typeface="Inter"/>
+              </a:rPr>
+              <a:t>•  </a:t>
+            </a:r>
+            <a:r>
               <a:rPr sz="1600" b="1">
                 <a:solidFill>
                   <a:srgbClr val="7EE787"/>
@@ -10899,7 +10926,7 @@
                 </a:solidFill>
                 <a:latin typeface="Inter"/>
               </a:rPr>
-              <a:t>: stop when no new edges are decimated, or all edges resolved.</a:t>
+              <a:t>: stop when no new edges decimated or all resolved.</a:t>
             </a:r>
           </a:p>
         </p:txBody>
@@ -10913,8 +10940,8 @@
           <p:nvPr/>
         </p:nvGraphicFramePr>
         <p:xfrm>
-          <a:off x="713232" y="2577168"/>
-          <a:ext cx="10765230" cy="1920240"/>
+          <a:off x="713232" y="2302848"/>
+          <a:ext cx="10765230" cy="1600200"/>
         </p:xfrm>
         <a:graphic>
           <a:graphicData uri="http://schemas.openxmlformats.org/drawingml/2006/table">
@@ -11151,93 +11178,7 @@
                           </a:solidFill>
                           <a:latin typeface="Inter"/>
                         </a:rPr>
-                        <a:t>Ego-graph queries f_v(x_{e1},...,x_{ed})</a:t>
-                      </a:r>
-                    </a:p>
-                  </a:txBody>
-                  <a:tcPr marL="72000" marR="72000" marT="36000" marB="36000">
-                    <a:solidFill>
-                      <a:srgbClr val="0D1117"/>
-                    </a:solidFill>
-                    <a:lnL w="6350">
-                      <a:solidFill>
-                        <a:srgbClr val="30363D"/>
-                      </a:solidFill>
-                    </a:lnL>
-                    <a:lnR w="6350">
-                      <a:solidFill>
-                        <a:srgbClr val="30363D"/>
-                      </a:solidFill>
-                    </a:lnR>
-                    <a:lnT w="6350">
-                      <a:solidFill>
-                        <a:srgbClr val="30363D"/>
-                      </a:solidFill>
-                    </a:lnT>
-                    <a:lnB w="6350">
-                      <a:solidFill>
-                        <a:srgbClr val="30363D"/>
-                      </a:solidFill>
-                    </a:lnB>
-                  </a:tcPr>
-                </a:tc>
-              </a:tr>
-              <a:tr h="320040">
-                <a:tc>
-                  <a:txBody>
-                    <a:bodyPr/>
-                    <a:lstStyle/>
-                    <a:p>
-                      <a:r>
-                        <a:rPr sz="1300">
-                          <a:solidFill>
-                            <a:srgbClr val="8B949E"/>
-                          </a:solidFill>
-                          <a:latin typeface="Inter"/>
-                        </a:rPr>
-                        <a:t>Warnings</a:t>
-                      </a:r>
-                    </a:p>
-                  </a:txBody>
-                  <a:tcPr marL="72000" marR="72000" marT="36000" marB="36000">
-                    <a:solidFill>
-                      <a:srgbClr val="0D1117"/>
-                    </a:solidFill>
-                    <a:lnL w="6350">
-                      <a:solidFill>
-                        <a:srgbClr val="30363D"/>
-                      </a:solidFill>
-                    </a:lnL>
-                    <a:lnR w="6350">
-                      <a:solidFill>
-                        <a:srgbClr val="30363D"/>
-                      </a:solidFill>
-                    </a:lnR>
-                    <a:lnT w="6350">
-                      <a:solidFill>
-                        <a:srgbClr val="30363D"/>
-                      </a:solidFill>
-                    </a:lnT>
-                    <a:lnB w="6350">
-                      <a:solidFill>
-                        <a:srgbClr val="30363D"/>
-                      </a:solidFill>
-                    </a:lnB>
-                  </a:tcPr>
-                </a:tc>
-                <a:tc>
-                  <a:txBody>
-                    <a:bodyPr/>
-                    <a:lstStyle/>
-                    <a:p>
-                      <a:r>
-                        <a:rPr sz="1300">
-                          <a:solidFill>
-                            <a:srgbClr val="8B949E"/>
-                          </a:solidFill>
-                          <a:latin typeface="Inter"/>
-                        </a:rPr>
-                        <a:t>LLM vote distributions per edge</a:t>
+                        <a:t>Ego-graph queries f_v(x_{e1}, …, x_{ed})</a:t>
                       </a:r>
                     </a:p>
                   </a:txBody>
@@ -11409,7 +11350,7 @@
                           </a:solidFill>
                           <a:latin typeface="Inter"/>
                         </a:rPr>
-                        <a:t>Feed established edges as context into next round</a:t>
+                        <a:t>Established edges as context into next round</a:t>
                       </a:r>
                     </a:p>
                   </a:txBody>

</xml_diff>